<commit_message>
Use reproducible synthetic survey and refresh model results
</commit_message>
<xml_diff>
--- a/docs/Presentacionfinal_Beatriz_Velayos.pptx
+++ b/docs/Presentacionfinal_Beatriz_Velayos.pptx
@@ -2,21 +2,21 @@
 <file path=ppt/presentation.xml><?xml version="1.0" encoding="utf-8"?>
 <p:presentation xmlns:p="http://schemas.openxmlformats.org/presentationml/2006/main">
   <p:sldMasterIdLst>
-    <p:sldMasterId xmlns:r="http://schemas.openxmlformats.org/officeDocument/2006/relationships" id="2147483648" r:id="R60705c9ce11d4871"/>
+    <p:sldMasterId xmlns:r="http://schemas.openxmlformats.org/officeDocument/2006/relationships" id="2147483648" r:id="R920ee6e08ca14a30"/>
   </p:sldMasterIdLst>
   <p:notesMasterIdLst>
-    <p:notesMasterId xmlns:r="http://schemas.openxmlformats.org/officeDocument/2006/relationships" r:id="Rddb9b49042ca458b"/>
+    <p:notesMasterId xmlns:r="http://schemas.openxmlformats.org/officeDocument/2006/relationships" r:id="Rc18abee1cf904653"/>
   </p:notesMasterIdLst>
   <p:sldIdLst>
-    <p:sldId xmlns:r="http://schemas.openxmlformats.org/officeDocument/2006/relationships" id="256" r:id="R13a1db4af5c34353"/>
-    <p:sldId xmlns:r="http://schemas.openxmlformats.org/officeDocument/2006/relationships" id="257" r:id="R1b88d509fe1a4d2a"/>
-    <p:sldId xmlns:r="http://schemas.openxmlformats.org/officeDocument/2006/relationships" id="258" r:id="R79f7297b6dd84b44"/>
-    <p:sldId xmlns:r="http://schemas.openxmlformats.org/officeDocument/2006/relationships" id="259" r:id="Rf8656044e1404aa2"/>
-    <p:sldId xmlns:r="http://schemas.openxmlformats.org/officeDocument/2006/relationships" id="260" r:id="R39b033d4c9fe4670"/>
-    <p:sldId xmlns:r="http://schemas.openxmlformats.org/officeDocument/2006/relationships" id="261" r:id="Ra70e60ee0094428e"/>
-    <p:sldId xmlns:r="http://schemas.openxmlformats.org/officeDocument/2006/relationships" id="262" r:id="Rd6886ddd08be455d"/>
-    <p:sldId xmlns:r="http://schemas.openxmlformats.org/officeDocument/2006/relationships" id="263" r:id="Rf5228561953c45aa"/>
-    <p:sldId xmlns:r="http://schemas.openxmlformats.org/officeDocument/2006/relationships" id="264" r:id="Rc5cf0ffd8d99474d"/>
+    <p:sldId xmlns:r="http://schemas.openxmlformats.org/officeDocument/2006/relationships" id="256" r:id="Rb7e3045f62f64186"/>
+    <p:sldId xmlns:r="http://schemas.openxmlformats.org/officeDocument/2006/relationships" id="257" r:id="Reb87d4455d4f42bb"/>
+    <p:sldId xmlns:r="http://schemas.openxmlformats.org/officeDocument/2006/relationships" id="258" r:id="R9af9561cf9ca4f48"/>
+    <p:sldId xmlns:r="http://schemas.openxmlformats.org/officeDocument/2006/relationships" id="259" r:id="R62fd65e3b5ec40cb"/>
+    <p:sldId xmlns:r="http://schemas.openxmlformats.org/officeDocument/2006/relationships" id="260" r:id="R0845afac9ab04004"/>
+    <p:sldId xmlns:r="http://schemas.openxmlformats.org/officeDocument/2006/relationships" id="261" r:id="R518ef7a12fdc4a10"/>
+    <p:sldId xmlns:r="http://schemas.openxmlformats.org/officeDocument/2006/relationships" id="262" r:id="R665b4b39c0044d57"/>
+    <p:sldId xmlns:r="http://schemas.openxmlformats.org/officeDocument/2006/relationships" id="263" r:id="R866856b247ec449d"/>
+    <p:sldId xmlns:r="http://schemas.openxmlformats.org/officeDocument/2006/relationships" id="264" r:id="Re2c65571406d4afb"/>
   </p:sldIdLst>
   <p:sldSz cx="12192000" cy="6858000"/>
   <p:notesSz cx="6858000" cy="9144000"/>
@@ -391,7 +391,7 @@
                 <a:ea typeface="Arial"/>
                 <a:cs typeface="Arial"/>
               </a:rPr>
-              <a:t>Proyecto educativo de bootcamp. Los datos son de ejemplo y el modelo no está validado para uso laboral. No representa un sistema para decidir sobre empleados.</a:t>
+              <a:t>Proyecto educativo de bootcamp. La encuesta de clima es sintética. Los datos son de ejemplo y el modelo no está validado para uso laboral. No representa un sistema para decidir sobre empleados.</a:t>
             </a:r>
             <a:endParaRPr sz="2000" b="0" u="none">
               <a:solidFill>
@@ -667,7 +667,7 @@
                 <a:ea typeface="Arial"/>
                 <a:cs typeface="Arial"/>
               </a:rPr>
-              <a:t>Métricas guardadas calculadas con predicciones out-of-fold. El código corrigió después la alineación de umbrales; el entrenamiento no se pudo regenerar en este entorno. Recalcular antes de citar cifras definitivas.</a:t>
+              <a:t>Resultados regenerados con validación cruzada estratificada OOF de cinco particiones. ROC-AUC: LogReg 0,819; RF 0,810; MLP 0,768. F1 y umbral se optimizan sobre las mismas predicciones: resultados exploratorios.</a:t>
             </a:r>
             <a:endParaRPr sz="2000" b="0" u="none">
               <a:solidFill>
@@ -1127,7 +1127,7 @@
                 <a:ea typeface="Arial"/>
                 <a:cs typeface="Arial"/>
               </a:rPr>
-              <a:t>Limitaciones principales: procedencia/licencia de la encuesta sin verificar; conjunto de demostración; métricas exploratorias; sin validación temporal, calibración, ni análisis formal de equidad. No emplear en decisiones de RRHH.</a:t>
+              <a:t>Limitaciones principales: sin validación independiente de las métricas; conjunto de demostración; métricas exploratorias; sin validación temporal, calibración, ni análisis formal de equidad. No emplear en decisiones de RRHH.</a:t>
             </a:r>
             <a:endParaRPr sz="2000" b="0" u="none">
               <a:solidFill>
@@ -7446,17 +7446,17 @@
   </p:cSld>
   <p:clrMap bg1="lt1" tx1="dk1" bg2="lt2" tx2="dk2" accent1="accent1" accent2="accent2" accent3="accent3" accent4="accent4" accent5="accent5" accent6="accent6" hlink="hlink" folHlink="folHlink"/>
   <p:sldLayoutIdLst>
-    <p:sldLayoutId xmlns:r="http://schemas.openxmlformats.org/officeDocument/2006/relationships" id="2147483649" r:id="R9e840044cecb4e81"/>
-    <p:sldLayoutId xmlns:r="http://schemas.openxmlformats.org/officeDocument/2006/relationships" id="2147483650" r:id="R8d098b2d8631469f"/>
-    <p:sldLayoutId xmlns:r="http://schemas.openxmlformats.org/officeDocument/2006/relationships" id="2147483651" r:id="R2aeb298c6d424a7c"/>
-    <p:sldLayoutId xmlns:r="http://schemas.openxmlformats.org/officeDocument/2006/relationships" id="2147483652" r:id="R3a6d3a32c66d446a"/>
-    <p:sldLayoutId xmlns:r="http://schemas.openxmlformats.org/officeDocument/2006/relationships" id="2147483653" r:id="R1b6e80f28f17423c"/>
-    <p:sldLayoutId xmlns:r="http://schemas.openxmlformats.org/officeDocument/2006/relationships" id="2147483654" r:id="R02ef8af9590343f7"/>
-    <p:sldLayoutId xmlns:r="http://schemas.openxmlformats.org/officeDocument/2006/relationships" id="2147483655" r:id="Rdae79996af1a4f4a"/>
-    <p:sldLayoutId xmlns:r="http://schemas.openxmlformats.org/officeDocument/2006/relationships" id="2147483656" r:id="R5756cfcd9f1f47ca"/>
-    <p:sldLayoutId xmlns:r="http://schemas.openxmlformats.org/officeDocument/2006/relationships" id="2147483657" r:id="Rfb694b4fbc354384"/>
-    <p:sldLayoutId xmlns:r="http://schemas.openxmlformats.org/officeDocument/2006/relationships" id="2147483658" r:id="R86b493953aae43ac"/>
-    <p:sldLayoutId xmlns:r="http://schemas.openxmlformats.org/officeDocument/2006/relationships" id="2147483659" r:id="R5bb110239dd74000"/>
+    <p:sldLayoutId xmlns:r="http://schemas.openxmlformats.org/officeDocument/2006/relationships" id="2147483649" r:id="Rdec6cc169e3f40d0"/>
+    <p:sldLayoutId xmlns:r="http://schemas.openxmlformats.org/officeDocument/2006/relationships" id="2147483650" r:id="R4f797e11bad64a4c"/>
+    <p:sldLayoutId xmlns:r="http://schemas.openxmlformats.org/officeDocument/2006/relationships" id="2147483651" r:id="R94c73a1da7434a29"/>
+    <p:sldLayoutId xmlns:r="http://schemas.openxmlformats.org/officeDocument/2006/relationships" id="2147483652" r:id="R7ac09b0daafc47b5"/>
+    <p:sldLayoutId xmlns:r="http://schemas.openxmlformats.org/officeDocument/2006/relationships" id="2147483653" r:id="R7eabc3fee0c34e4c"/>
+    <p:sldLayoutId xmlns:r="http://schemas.openxmlformats.org/officeDocument/2006/relationships" id="2147483654" r:id="Ra4d9156aeae34ca5"/>
+    <p:sldLayoutId xmlns:r="http://schemas.openxmlformats.org/officeDocument/2006/relationships" id="2147483655" r:id="R997c6cc9931e49f2"/>
+    <p:sldLayoutId xmlns:r="http://schemas.openxmlformats.org/officeDocument/2006/relationships" id="2147483656" r:id="Rcffce90afeec42c1"/>
+    <p:sldLayoutId xmlns:r="http://schemas.openxmlformats.org/officeDocument/2006/relationships" id="2147483657" r:id="Rbed39a8dd11847fc"/>
+    <p:sldLayoutId xmlns:r="http://schemas.openxmlformats.org/officeDocument/2006/relationships" id="2147483658" r:id="R487314aae1e74eff"/>
+    <p:sldLayoutId xmlns:r="http://schemas.openxmlformats.org/officeDocument/2006/relationships" id="2147483659" r:id="R493e122bdf8d450d"/>
   </p:sldLayoutIdLst>
 </p:sldMaster>
 </file>
@@ -8523,8 +8523,8 @@
           <p:nvPr/>
         </p:nvPicPr>
         <p:blipFill>
-          <a:blip ns3:embed="R367a84ca3dbe4c8c"/>
-          <a:srcRect l="5" t="0" r="5" b="0"/>
+          <a:blip ns3:embed="R3b8d19d532854d61"/>
+          <a:srcRect l="10091" t="0" r="10091" b="0"/>
           <a:stretch>
             <a:fillRect l="0" t="0" r="0" b="0"/>
           </a:stretch>
@@ -8596,7 +8596,7 @@
                 <a:ea typeface="Calibri"/>
                 <a:cs typeface="Calibri"/>
               </a:rPr>
-              <a:t>Artefacto histórico; recalcular métricas antes de citar cifras definitivas.</a:t>
+              <a:t>CV OOF (5 particiones): ROC-AUC 0,819 · PR-AUC 0,552 · F1* 0,533. *Umbral optimizado en las mismas predicciones.</a:t>
             </a:r>
             <a:endParaRPr sz="1400" b="0" u="none">
               <a:solidFill>
@@ -8703,8 +8703,8 @@
           <p:nvPr/>
         </p:nvPicPr>
         <p:blipFill>
-          <a:blip ns3:embed="R4c978ff755ad411d"/>
-          <a:srcRect l="5" t="0" r="5" b="0"/>
+          <a:blip ns3:embed="R0d4ab046ff3d4cc9"/>
+          <a:srcRect l="0" t="2" r="0" b="2"/>
           <a:stretch>
             <a:fillRect l="0" t="0" r="0" b="0"/>
           </a:stretch>
@@ -8883,8 +8883,8 @@
           <p:nvPr/>
         </p:nvPicPr>
         <p:blipFill>
-          <a:blip ns3:embed="Rc70c9de0618d4a9a"/>
-          <a:srcRect l="5" t="0" r="5" b="0"/>
+          <a:blip ns3:embed="R79c70b4dc4b24651"/>
+          <a:srcRect l="0" t="2" r="0" b="2"/>
           <a:stretch>
             <a:fillRect l="0" t="0" r="0" b="0"/>
           </a:stretch>
@@ -9063,8 +9063,8 @@
           <p:nvPr/>
         </p:nvPicPr>
         <p:blipFill>
-          <a:blip ns3:embed="Re4951305b6f14fb1"/>
-          <a:srcRect l="5" t="0" r="5" b="0"/>
+          <a:blip ns3:embed="R6e0fc8d224ac4fe6"/>
+          <a:srcRect l="0" t="2" r="0" b="2"/>
           <a:stretch>
             <a:fillRect l="0" t="0" r="0" b="0"/>
           </a:stretch>
@@ -9243,8 +9243,8 @@
           <p:nvPr/>
         </p:nvPicPr>
         <p:blipFill>
-          <a:blip ns3:embed="R16c02274b6e44898"/>
-          <a:srcRect l="5" t="0" r="5" b="0"/>
+          <a:blip ns3:embed="R06fcd7290743433c"/>
+          <a:srcRect l="0" t="2" r="0" b="2"/>
           <a:stretch>
             <a:fillRect l="0" t="0" r="0" b="0"/>
           </a:stretch>
@@ -9471,7 +9471,7 @@
                 <a:ea typeface="Calibri"/>
                 <a:cs typeface="Calibri"/>
               </a:rPr>
-              <a:t>Recuperar y verificar la fuente y licencia de encuesta_clima.csv.</a:t>
+              <a:t>La encuesta de clima es sintética y reproducible; no representa respuestas reales.</a:t>
             </a:r>
             <a:endParaRPr sz="3200" b="0" u="none">
               <a:solidFill>

</xml_diff>

<commit_message>
Refresh portfolio artifacts from regenerated models
</commit_message>
<xml_diff>
--- a/docs/Presentacionfinal_Beatriz_Velayos.pptx
+++ b/docs/Presentacionfinal_Beatriz_Velayos.pptx
@@ -2,21 +2,21 @@
 <file path=ppt/presentation.xml><?xml version="1.0" encoding="utf-8"?>
 <p:presentation xmlns:p="http://schemas.openxmlformats.org/presentationml/2006/main">
   <p:sldMasterIdLst>
-    <p:sldMasterId xmlns:r="http://schemas.openxmlformats.org/officeDocument/2006/relationships" id="2147483648" r:id="R920ee6e08ca14a30"/>
+    <p:sldMasterId xmlns:r="http://schemas.openxmlformats.org/officeDocument/2006/relationships" id="2147483648" r:id="Rc2690c94295e4d30"/>
   </p:sldMasterIdLst>
   <p:notesMasterIdLst>
-    <p:notesMasterId xmlns:r="http://schemas.openxmlformats.org/officeDocument/2006/relationships" r:id="Rc18abee1cf904653"/>
+    <p:notesMasterId xmlns:r="http://schemas.openxmlformats.org/officeDocument/2006/relationships" r:id="R3f8e922c0c174ce6"/>
   </p:notesMasterIdLst>
   <p:sldIdLst>
-    <p:sldId xmlns:r="http://schemas.openxmlformats.org/officeDocument/2006/relationships" id="256" r:id="Rb7e3045f62f64186"/>
-    <p:sldId xmlns:r="http://schemas.openxmlformats.org/officeDocument/2006/relationships" id="257" r:id="Reb87d4455d4f42bb"/>
-    <p:sldId xmlns:r="http://schemas.openxmlformats.org/officeDocument/2006/relationships" id="258" r:id="R9af9561cf9ca4f48"/>
-    <p:sldId xmlns:r="http://schemas.openxmlformats.org/officeDocument/2006/relationships" id="259" r:id="R62fd65e3b5ec40cb"/>
-    <p:sldId xmlns:r="http://schemas.openxmlformats.org/officeDocument/2006/relationships" id="260" r:id="R0845afac9ab04004"/>
-    <p:sldId xmlns:r="http://schemas.openxmlformats.org/officeDocument/2006/relationships" id="261" r:id="R518ef7a12fdc4a10"/>
-    <p:sldId xmlns:r="http://schemas.openxmlformats.org/officeDocument/2006/relationships" id="262" r:id="R665b4b39c0044d57"/>
-    <p:sldId xmlns:r="http://schemas.openxmlformats.org/officeDocument/2006/relationships" id="263" r:id="R866856b247ec449d"/>
-    <p:sldId xmlns:r="http://schemas.openxmlformats.org/officeDocument/2006/relationships" id="264" r:id="Re2c65571406d4afb"/>
+    <p:sldId xmlns:r="http://schemas.openxmlformats.org/officeDocument/2006/relationships" id="256" r:id="R0515cbd4805348c3"/>
+    <p:sldId xmlns:r="http://schemas.openxmlformats.org/officeDocument/2006/relationships" id="257" r:id="Re9a46493142b41b4"/>
+    <p:sldId xmlns:r="http://schemas.openxmlformats.org/officeDocument/2006/relationships" id="258" r:id="R8d664915d1e44c56"/>
+    <p:sldId xmlns:r="http://schemas.openxmlformats.org/officeDocument/2006/relationships" id="259" r:id="Raec4e1197698474e"/>
+    <p:sldId xmlns:r="http://schemas.openxmlformats.org/officeDocument/2006/relationships" id="260" r:id="Rd79f369423944e39"/>
+    <p:sldId xmlns:r="http://schemas.openxmlformats.org/officeDocument/2006/relationships" id="261" r:id="R9e1c154c05d74144"/>
+    <p:sldId xmlns:r="http://schemas.openxmlformats.org/officeDocument/2006/relationships" id="262" r:id="Ra084ce721c2a465a"/>
+    <p:sldId xmlns:r="http://schemas.openxmlformats.org/officeDocument/2006/relationships" id="263" r:id="Rb7cb05586f7e410f"/>
+    <p:sldId xmlns:r="http://schemas.openxmlformats.org/officeDocument/2006/relationships" id="264" r:id="Rebea183ea7104db0"/>
   </p:sldIdLst>
   <p:sldSz cx="12192000" cy="6858000"/>
   <p:notesSz cx="6858000" cy="9144000"/>
@@ -7446,17 +7446,17 @@
   </p:cSld>
   <p:clrMap bg1="lt1" tx1="dk1" bg2="lt2" tx2="dk2" accent1="accent1" accent2="accent2" accent3="accent3" accent4="accent4" accent5="accent5" accent6="accent6" hlink="hlink" folHlink="folHlink"/>
   <p:sldLayoutIdLst>
-    <p:sldLayoutId xmlns:r="http://schemas.openxmlformats.org/officeDocument/2006/relationships" id="2147483649" r:id="Rdec6cc169e3f40d0"/>
-    <p:sldLayoutId xmlns:r="http://schemas.openxmlformats.org/officeDocument/2006/relationships" id="2147483650" r:id="R4f797e11bad64a4c"/>
-    <p:sldLayoutId xmlns:r="http://schemas.openxmlformats.org/officeDocument/2006/relationships" id="2147483651" r:id="R94c73a1da7434a29"/>
-    <p:sldLayoutId xmlns:r="http://schemas.openxmlformats.org/officeDocument/2006/relationships" id="2147483652" r:id="R7ac09b0daafc47b5"/>
-    <p:sldLayoutId xmlns:r="http://schemas.openxmlformats.org/officeDocument/2006/relationships" id="2147483653" r:id="R7eabc3fee0c34e4c"/>
-    <p:sldLayoutId xmlns:r="http://schemas.openxmlformats.org/officeDocument/2006/relationships" id="2147483654" r:id="Ra4d9156aeae34ca5"/>
-    <p:sldLayoutId xmlns:r="http://schemas.openxmlformats.org/officeDocument/2006/relationships" id="2147483655" r:id="R997c6cc9931e49f2"/>
-    <p:sldLayoutId xmlns:r="http://schemas.openxmlformats.org/officeDocument/2006/relationships" id="2147483656" r:id="Rcffce90afeec42c1"/>
-    <p:sldLayoutId xmlns:r="http://schemas.openxmlformats.org/officeDocument/2006/relationships" id="2147483657" r:id="Rbed39a8dd11847fc"/>
-    <p:sldLayoutId xmlns:r="http://schemas.openxmlformats.org/officeDocument/2006/relationships" id="2147483658" r:id="R487314aae1e74eff"/>
-    <p:sldLayoutId xmlns:r="http://schemas.openxmlformats.org/officeDocument/2006/relationships" id="2147483659" r:id="R493e122bdf8d450d"/>
+    <p:sldLayoutId xmlns:r="http://schemas.openxmlformats.org/officeDocument/2006/relationships" id="2147483649" r:id="R9a7e9b45be69455f"/>
+    <p:sldLayoutId xmlns:r="http://schemas.openxmlformats.org/officeDocument/2006/relationships" id="2147483650" r:id="Ra9698adb96ce4be9"/>
+    <p:sldLayoutId xmlns:r="http://schemas.openxmlformats.org/officeDocument/2006/relationships" id="2147483651" r:id="Rf6dba9bbe3dc49d2"/>
+    <p:sldLayoutId xmlns:r="http://schemas.openxmlformats.org/officeDocument/2006/relationships" id="2147483652" r:id="Raa421203e92142b2"/>
+    <p:sldLayoutId xmlns:r="http://schemas.openxmlformats.org/officeDocument/2006/relationships" id="2147483653" r:id="R0a8787cfcdaa43cd"/>
+    <p:sldLayoutId xmlns:r="http://schemas.openxmlformats.org/officeDocument/2006/relationships" id="2147483654" r:id="Rcb1b06b266b94c09"/>
+    <p:sldLayoutId xmlns:r="http://schemas.openxmlformats.org/officeDocument/2006/relationships" id="2147483655" r:id="R993593165a294e87"/>
+    <p:sldLayoutId xmlns:r="http://schemas.openxmlformats.org/officeDocument/2006/relationships" id="2147483656" r:id="Rb9a8857a107142e9"/>
+    <p:sldLayoutId xmlns:r="http://schemas.openxmlformats.org/officeDocument/2006/relationships" id="2147483657" r:id="R5722ce4665494e32"/>
+    <p:sldLayoutId xmlns:r="http://schemas.openxmlformats.org/officeDocument/2006/relationships" id="2147483658" r:id="R544d0a3ea5804800"/>
+    <p:sldLayoutId xmlns:r="http://schemas.openxmlformats.org/officeDocument/2006/relationships" id="2147483659" r:id="Rb295170fe88845fd"/>
   </p:sldLayoutIdLst>
 </p:sldMaster>
 </file>
@@ -8523,7 +8523,7 @@
           <p:nvPr/>
         </p:nvPicPr>
         <p:blipFill>
-          <a:blip ns3:embed="R3b8d19d532854d61"/>
+          <a:blip ns3:embed="Rd287d0089f194840"/>
           <a:srcRect l="10091" t="0" r="10091" b="0"/>
           <a:stretch>
             <a:fillRect l="0" t="0" r="0" b="0"/>
@@ -8703,7 +8703,7 @@
           <p:nvPr/>
         </p:nvPicPr>
         <p:blipFill>
-          <a:blip ns3:embed="R0d4ab046ff3d4cc9"/>
+          <a:blip ns3:embed="R8ed1848927bb4062"/>
           <a:srcRect l="0" t="2" r="0" b="2"/>
           <a:stretch>
             <a:fillRect l="0" t="0" r="0" b="0"/>
@@ -8883,7 +8883,7 @@
           <p:nvPr/>
         </p:nvPicPr>
         <p:blipFill>
-          <a:blip ns3:embed="R79c70b4dc4b24651"/>
+          <a:blip ns3:embed="R4a578b1edecf48a6"/>
           <a:srcRect l="0" t="2" r="0" b="2"/>
           <a:stretch>
             <a:fillRect l="0" t="0" r="0" b="0"/>
@@ -9063,7 +9063,7 @@
           <p:nvPr/>
         </p:nvPicPr>
         <p:blipFill>
-          <a:blip ns3:embed="R6e0fc8d224ac4fe6"/>
+          <a:blip ns3:embed="R22d906f4f43e4ffd"/>
           <a:srcRect l="0" t="2" r="0" b="2"/>
           <a:stretch>
             <a:fillRect l="0" t="0" r="0" b="0"/>
@@ -9243,8 +9243,8 @@
           <p:nvPr/>
         </p:nvPicPr>
         <p:blipFill>
-          <a:blip ns3:embed="R06fcd7290743433c"/>
-          <a:srcRect l="0" t="2" r="0" b="2"/>
+          <a:blip ns3:embed="Rdf0a28d1f8334f7d"/>
+          <a:srcRect l="10386" t="0" r="10386" b="0"/>
           <a:stretch>
             <a:fillRect l="0" t="0" r="0" b="0"/>
           </a:stretch>

</xml_diff>

<commit_message>
Document model regeneration environment and include MLP artifact
</commit_message>
<xml_diff>
--- a/docs/Presentacionfinal_Beatriz_Velayos.pptx
+++ b/docs/Presentacionfinal_Beatriz_Velayos.pptx
@@ -2,21 +2,21 @@
 <file path=ppt/presentation.xml><?xml version="1.0" encoding="utf-8"?>
 <p:presentation xmlns:p="http://schemas.openxmlformats.org/presentationml/2006/main">
   <p:sldMasterIdLst>
-    <p:sldMasterId xmlns:r="http://schemas.openxmlformats.org/officeDocument/2006/relationships" id="2147483648" r:id="Rc2690c94295e4d30"/>
+    <p:sldMasterId xmlns:r="http://schemas.openxmlformats.org/officeDocument/2006/relationships" id="2147483648" r:id="Rd7035214d2504c1c"/>
   </p:sldMasterIdLst>
   <p:notesMasterIdLst>
-    <p:notesMasterId xmlns:r="http://schemas.openxmlformats.org/officeDocument/2006/relationships" r:id="R3f8e922c0c174ce6"/>
+    <p:notesMasterId xmlns:r="http://schemas.openxmlformats.org/officeDocument/2006/relationships" r:id="R505400e243c84aa3"/>
   </p:notesMasterIdLst>
   <p:sldIdLst>
-    <p:sldId xmlns:r="http://schemas.openxmlformats.org/officeDocument/2006/relationships" id="256" r:id="R0515cbd4805348c3"/>
-    <p:sldId xmlns:r="http://schemas.openxmlformats.org/officeDocument/2006/relationships" id="257" r:id="Re9a46493142b41b4"/>
-    <p:sldId xmlns:r="http://schemas.openxmlformats.org/officeDocument/2006/relationships" id="258" r:id="R8d664915d1e44c56"/>
-    <p:sldId xmlns:r="http://schemas.openxmlformats.org/officeDocument/2006/relationships" id="259" r:id="Raec4e1197698474e"/>
-    <p:sldId xmlns:r="http://schemas.openxmlformats.org/officeDocument/2006/relationships" id="260" r:id="Rd79f369423944e39"/>
-    <p:sldId xmlns:r="http://schemas.openxmlformats.org/officeDocument/2006/relationships" id="261" r:id="R9e1c154c05d74144"/>
-    <p:sldId xmlns:r="http://schemas.openxmlformats.org/officeDocument/2006/relationships" id="262" r:id="Ra084ce721c2a465a"/>
-    <p:sldId xmlns:r="http://schemas.openxmlformats.org/officeDocument/2006/relationships" id="263" r:id="Rb7cb05586f7e410f"/>
-    <p:sldId xmlns:r="http://schemas.openxmlformats.org/officeDocument/2006/relationships" id="264" r:id="Rebea183ea7104db0"/>
+    <p:sldId xmlns:r="http://schemas.openxmlformats.org/officeDocument/2006/relationships" id="256" r:id="R0267298e712546c7"/>
+    <p:sldId xmlns:r="http://schemas.openxmlformats.org/officeDocument/2006/relationships" id="257" r:id="R08fa30da6d504aff"/>
+    <p:sldId xmlns:r="http://schemas.openxmlformats.org/officeDocument/2006/relationships" id="258" r:id="R12909c66be3f4827"/>
+    <p:sldId xmlns:r="http://schemas.openxmlformats.org/officeDocument/2006/relationships" id="259" r:id="R94d7037cdd864cc3"/>
+    <p:sldId xmlns:r="http://schemas.openxmlformats.org/officeDocument/2006/relationships" id="260" r:id="R795d891c55ea4947"/>
+    <p:sldId xmlns:r="http://schemas.openxmlformats.org/officeDocument/2006/relationships" id="261" r:id="Rd839ed8c87ef498d"/>
+    <p:sldId xmlns:r="http://schemas.openxmlformats.org/officeDocument/2006/relationships" id="262" r:id="R9e62e59ac12544f0"/>
+    <p:sldId xmlns:r="http://schemas.openxmlformats.org/officeDocument/2006/relationships" id="263" r:id="Rdb09108515de4f49"/>
+    <p:sldId xmlns:r="http://schemas.openxmlformats.org/officeDocument/2006/relationships" id="264" r:id="Rdccf1317366f4883"/>
   </p:sldIdLst>
   <p:sldSz cx="12192000" cy="6858000"/>
   <p:notesSz cx="6858000" cy="9144000"/>
@@ -575,7 +575,7 @@
                 <a:ea typeface="Arial"/>
                 <a:cs typeface="Arial"/>
               </a:rPr>
-              <a:t>La unión se realiza por EmployeeNumber. Evitar asegurar ausencia de errores sin revisar el informe generado. Spark ejecuta por defecto en local[*].</a:t>
+              <a:t>La unión se realiza por EmployeeNumber. La regeneración de métricas usó un Parquet local con el esquema del ETL; este entorno no tenía Docker Compose ni PySpark para ejecutar Spark de extremo a extremo.</a:t>
             </a:r>
             <a:endParaRPr sz="2000" b="0" u="none">
               <a:solidFill>
@@ -7446,17 +7446,17 @@
   </p:cSld>
   <p:clrMap bg1="lt1" tx1="dk1" bg2="lt2" tx2="dk2" accent1="accent1" accent2="accent2" accent3="accent3" accent4="accent4" accent5="accent5" accent6="accent6" hlink="hlink" folHlink="folHlink"/>
   <p:sldLayoutIdLst>
-    <p:sldLayoutId xmlns:r="http://schemas.openxmlformats.org/officeDocument/2006/relationships" id="2147483649" r:id="R9a7e9b45be69455f"/>
-    <p:sldLayoutId xmlns:r="http://schemas.openxmlformats.org/officeDocument/2006/relationships" id="2147483650" r:id="Ra9698adb96ce4be9"/>
-    <p:sldLayoutId xmlns:r="http://schemas.openxmlformats.org/officeDocument/2006/relationships" id="2147483651" r:id="Rf6dba9bbe3dc49d2"/>
-    <p:sldLayoutId xmlns:r="http://schemas.openxmlformats.org/officeDocument/2006/relationships" id="2147483652" r:id="Raa421203e92142b2"/>
-    <p:sldLayoutId xmlns:r="http://schemas.openxmlformats.org/officeDocument/2006/relationships" id="2147483653" r:id="R0a8787cfcdaa43cd"/>
-    <p:sldLayoutId xmlns:r="http://schemas.openxmlformats.org/officeDocument/2006/relationships" id="2147483654" r:id="Rcb1b06b266b94c09"/>
-    <p:sldLayoutId xmlns:r="http://schemas.openxmlformats.org/officeDocument/2006/relationships" id="2147483655" r:id="R993593165a294e87"/>
-    <p:sldLayoutId xmlns:r="http://schemas.openxmlformats.org/officeDocument/2006/relationships" id="2147483656" r:id="Rb9a8857a107142e9"/>
-    <p:sldLayoutId xmlns:r="http://schemas.openxmlformats.org/officeDocument/2006/relationships" id="2147483657" r:id="R5722ce4665494e32"/>
-    <p:sldLayoutId xmlns:r="http://schemas.openxmlformats.org/officeDocument/2006/relationships" id="2147483658" r:id="R544d0a3ea5804800"/>
-    <p:sldLayoutId xmlns:r="http://schemas.openxmlformats.org/officeDocument/2006/relationships" id="2147483659" r:id="Rb295170fe88845fd"/>
+    <p:sldLayoutId xmlns:r="http://schemas.openxmlformats.org/officeDocument/2006/relationships" id="2147483649" r:id="R48f5e498678d42f5"/>
+    <p:sldLayoutId xmlns:r="http://schemas.openxmlformats.org/officeDocument/2006/relationships" id="2147483650" r:id="Rc09905d17d36424a"/>
+    <p:sldLayoutId xmlns:r="http://schemas.openxmlformats.org/officeDocument/2006/relationships" id="2147483651" r:id="R917d4c61f40a4dd9"/>
+    <p:sldLayoutId xmlns:r="http://schemas.openxmlformats.org/officeDocument/2006/relationships" id="2147483652" r:id="R80713c17eb184eed"/>
+    <p:sldLayoutId xmlns:r="http://schemas.openxmlformats.org/officeDocument/2006/relationships" id="2147483653" r:id="Rf5fe3e2d79e44966"/>
+    <p:sldLayoutId xmlns:r="http://schemas.openxmlformats.org/officeDocument/2006/relationships" id="2147483654" r:id="R5bbc1a62bfcd44ff"/>
+    <p:sldLayoutId xmlns:r="http://schemas.openxmlformats.org/officeDocument/2006/relationships" id="2147483655" r:id="Rcb78f6e9ab284db6"/>
+    <p:sldLayoutId xmlns:r="http://schemas.openxmlformats.org/officeDocument/2006/relationships" id="2147483656" r:id="R56f3c581f9c5409d"/>
+    <p:sldLayoutId xmlns:r="http://schemas.openxmlformats.org/officeDocument/2006/relationships" id="2147483657" r:id="R66d8547b43e14f8d"/>
+    <p:sldLayoutId xmlns:r="http://schemas.openxmlformats.org/officeDocument/2006/relationships" id="2147483658" r:id="Rd6c872e8cefd4d84"/>
+    <p:sldLayoutId xmlns:r="http://schemas.openxmlformats.org/officeDocument/2006/relationships" id="2147483659" r:id="Rb1dce07d7e4e470a"/>
   </p:sldLayoutIdLst>
 </p:sldMaster>
 </file>
@@ -8523,7 +8523,7 @@
           <p:nvPr/>
         </p:nvPicPr>
         <p:blipFill>
-          <a:blip ns3:embed="Rd287d0089f194840"/>
+          <a:blip ns3:embed="Rfa4f3dab6622409a"/>
           <a:srcRect l="10091" t="0" r="10091" b="0"/>
           <a:stretch>
             <a:fillRect l="0" t="0" r="0" b="0"/>
@@ -8703,7 +8703,7 @@
           <p:nvPr/>
         </p:nvPicPr>
         <p:blipFill>
-          <a:blip ns3:embed="R8ed1848927bb4062"/>
+          <a:blip ns3:embed="R90fd4562b74449e1"/>
           <a:srcRect l="0" t="2" r="0" b="2"/>
           <a:stretch>
             <a:fillRect l="0" t="0" r="0" b="0"/>
@@ -8883,7 +8883,7 @@
           <p:nvPr/>
         </p:nvPicPr>
         <p:blipFill>
-          <a:blip ns3:embed="R4a578b1edecf48a6"/>
+          <a:blip ns3:embed="Rf645ae31368d4866"/>
           <a:srcRect l="0" t="2" r="0" b="2"/>
           <a:stretch>
             <a:fillRect l="0" t="0" r="0" b="0"/>
@@ -9063,7 +9063,7 @@
           <p:nvPr/>
         </p:nvPicPr>
         <p:blipFill>
-          <a:blip ns3:embed="R22d906f4f43e4ffd"/>
+          <a:blip ns3:embed="R31f7cadae9314834"/>
           <a:srcRect l="0" t="2" r="0" b="2"/>
           <a:stretch>
             <a:fillRect l="0" t="0" r="0" b="0"/>
@@ -9243,7 +9243,7 @@
           <p:nvPr/>
         </p:nvPicPr>
         <p:blipFill>
-          <a:blip ns3:embed="Rdf0a28d1f8334f7d"/>
+          <a:blip ns3:embed="R00ca465e016d4d74"/>
           <a:srcRect l="10386" t="0" r="10386" b="0"/>
           <a:stretch>
             <a:fillRect l="0" t="0" r="0" b="0"/>

</xml_diff>

<commit_message>
Fix chart framing in portfolio presentation
</commit_message>
<xml_diff>
--- a/docs/Presentacionfinal_Beatriz_Velayos.pptx
+++ b/docs/Presentacionfinal_Beatriz_Velayos.pptx
@@ -2,21 +2,21 @@
 <file path=ppt/presentation.xml><?xml version="1.0" encoding="utf-8"?>
 <p:presentation xmlns:p="http://schemas.openxmlformats.org/presentationml/2006/main">
   <p:sldMasterIdLst>
-    <p:sldMasterId xmlns:r="http://schemas.openxmlformats.org/officeDocument/2006/relationships" id="2147483648" r:id="Rd7035214d2504c1c"/>
+    <p:sldMasterId xmlns:r="http://schemas.openxmlformats.org/officeDocument/2006/relationships" id="2147483648" r:id="Rd06dc23cf74148de"/>
   </p:sldMasterIdLst>
   <p:notesMasterIdLst>
-    <p:notesMasterId xmlns:r="http://schemas.openxmlformats.org/officeDocument/2006/relationships" r:id="R505400e243c84aa3"/>
+    <p:notesMasterId xmlns:r="http://schemas.openxmlformats.org/officeDocument/2006/relationships" r:id="R3471bd9a9cf34996"/>
   </p:notesMasterIdLst>
   <p:sldIdLst>
-    <p:sldId xmlns:r="http://schemas.openxmlformats.org/officeDocument/2006/relationships" id="256" r:id="R0267298e712546c7"/>
-    <p:sldId xmlns:r="http://schemas.openxmlformats.org/officeDocument/2006/relationships" id="257" r:id="R08fa30da6d504aff"/>
-    <p:sldId xmlns:r="http://schemas.openxmlformats.org/officeDocument/2006/relationships" id="258" r:id="R12909c66be3f4827"/>
-    <p:sldId xmlns:r="http://schemas.openxmlformats.org/officeDocument/2006/relationships" id="259" r:id="R94d7037cdd864cc3"/>
-    <p:sldId xmlns:r="http://schemas.openxmlformats.org/officeDocument/2006/relationships" id="260" r:id="R795d891c55ea4947"/>
-    <p:sldId xmlns:r="http://schemas.openxmlformats.org/officeDocument/2006/relationships" id="261" r:id="Rd839ed8c87ef498d"/>
-    <p:sldId xmlns:r="http://schemas.openxmlformats.org/officeDocument/2006/relationships" id="262" r:id="R9e62e59ac12544f0"/>
-    <p:sldId xmlns:r="http://schemas.openxmlformats.org/officeDocument/2006/relationships" id="263" r:id="Rdb09108515de4f49"/>
-    <p:sldId xmlns:r="http://schemas.openxmlformats.org/officeDocument/2006/relationships" id="264" r:id="Rdccf1317366f4883"/>
+    <p:sldId xmlns:r="http://schemas.openxmlformats.org/officeDocument/2006/relationships" id="256" r:id="R3a7cf07b87b34fef"/>
+    <p:sldId xmlns:r="http://schemas.openxmlformats.org/officeDocument/2006/relationships" id="257" r:id="Reb4b304ba0e242a1"/>
+    <p:sldId xmlns:r="http://schemas.openxmlformats.org/officeDocument/2006/relationships" id="258" r:id="Ra7f7c8c586ed49ad"/>
+    <p:sldId xmlns:r="http://schemas.openxmlformats.org/officeDocument/2006/relationships" id="259" r:id="R1ebf9840015c41a2"/>
+    <p:sldId xmlns:r="http://schemas.openxmlformats.org/officeDocument/2006/relationships" id="260" r:id="Ra2cd0a0636474566"/>
+    <p:sldId xmlns:r="http://schemas.openxmlformats.org/officeDocument/2006/relationships" id="261" r:id="Rf6110d041e5a40bb"/>
+    <p:sldId xmlns:r="http://schemas.openxmlformats.org/officeDocument/2006/relationships" id="262" r:id="Rd2f34188ef4342fc"/>
+    <p:sldId xmlns:r="http://schemas.openxmlformats.org/officeDocument/2006/relationships" id="263" r:id="Rfd2c9da290b94128"/>
+    <p:sldId xmlns:r="http://schemas.openxmlformats.org/officeDocument/2006/relationships" id="264" r:id="Rc5159bec4de44d21"/>
   </p:sldIdLst>
   <p:sldSz cx="12192000" cy="6858000"/>
   <p:notesSz cx="6858000" cy="9144000"/>
@@ -7446,17 +7446,17 @@
   </p:cSld>
   <p:clrMap bg1="lt1" tx1="dk1" bg2="lt2" tx2="dk2" accent1="accent1" accent2="accent2" accent3="accent3" accent4="accent4" accent5="accent5" accent6="accent6" hlink="hlink" folHlink="folHlink"/>
   <p:sldLayoutIdLst>
-    <p:sldLayoutId xmlns:r="http://schemas.openxmlformats.org/officeDocument/2006/relationships" id="2147483649" r:id="R48f5e498678d42f5"/>
-    <p:sldLayoutId xmlns:r="http://schemas.openxmlformats.org/officeDocument/2006/relationships" id="2147483650" r:id="Rc09905d17d36424a"/>
-    <p:sldLayoutId xmlns:r="http://schemas.openxmlformats.org/officeDocument/2006/relationships" id="2147483651" r:id="R917d4c61f40a4dd9"/>
-    <p:sldLayoutId xmlns:r="http://schemas.openxmlformats.org/officeDocument/2006/relationships" id="2147483652" r:id="R80713c17eb184eed"/>
-    <p:sldLayoutId xmlns:r="http://schemas.openxmlformats.org/officeDocument/2006/relationships" id="2147483653" r:id="Rf5fe3e2d79e44966"/>
-    <p:sldLayoutId xmlns:r="http://schemas.openxmlformats.org/officeDocument/2006/relationships" id="2147483654" r:id="R5bbc1a62bfcd44ff"/>
-    <p:sldLayoutId xmlns:r="http://schemas.openxmlformats.org/officeDocument/2006/relationships" id="2147483655" r:id="Rcb78f6e9ab284db6"/>
-    <p:sldLayoutId xmlns:r="http://schemas.openxmlformats.org/officeDocument/2006/relationships" id="2147483656" r:id="R56f3c581f9c5409d"/>
-    <p:sldLayoutId xmlns:r="http://schemas.openxmlformats.org/officeDocument/2006/relationships" id="2147483657" r:id="R66d8547b43e14f8d"/>
-    <p:sldLayoutId xmlns:r="http://schemas.openxmlformats.org/officeDocument/2006/relationships" id="2147483658" r:id="Rd6c872e8cefd4d84"/>
-    <p:sldLayoutId xmlns:r="http://schemas.openxmlformats.org/officeDocument/2006/relationships" id="2147483659" r:id="Rb1dce07d7e4e470a"/>
+    <p:sldLayoutId xmlns:r="http://schemas.openxmlformats.org/officeDocument/2006/relationships" id="2147483649" r:id="Rece72d1d96634817"/>
+    <p:sldLayoutId xmlns:r="http://schemas.openxmlformats.org/officeDocument/2006/relationships" id="2147483650" r:id="Rea509c6b581a4a56"/>
+    <p:sldLayoutId xmlns:r="http://schemas.openxmlformats.org/officeDocument/2006/relationships" id="2147483651" r:id="R86c6efa15cc64cbb"/>
+    <p:sldLayoutId xmlns:r="http://schemas.openxmlformats.org/officeDocument/2006/relationships" id="2147483652" r:id="R2f24993626404f97"/>
+    <p:sldLayoutId xmlns:r="http://schemas.openxmlformats.org/officeDocument/2006/relationships" id="2147483653" r:id="Ra195f1f4a7e9415e"/>
+    <p:sldLayoutId xmlns:r="http://schemas.openxmlformats.org/officeDocument/2006/relationships" id="2147483654" r:id="R5dba4e6a716e42ea"/>
+    <p:sldLayoutId xmlns:r="http://schemas.openxmlformats.org/officeDocument/2006/relationships" id="2147483655" r:id="R5b8ceb797c4b49e4"/>
+    <p:sldLayoutId xmlns:r="http://schemas.openxmlformats.org/officeDocument/2006/relationships" id="2147483656" r:id="Rff668722085a45a3"/>
+    <p:sldLayoutId xmlns:r="http://schemas.openxmlformats.org/officeDocument/2006/relationships" id="2147483657" r:id="R60fe1f0df1ae4488"/>
+    <p:sldLayoutId xmlns:r="http://schemas.openxmlformats.org/officeDocument/2006/relationships" id="2147483658" r:id="R1a29a9cef6bc49b4"/>
+    <p:sldLayoutId xmlns:r="http://schemas.openxmlformats.org/officeDocument/2006/relationships" id="2147483659" r:id="R289cec33d29540b1"/>
   </p:sldLayoutIdLst>
 </p:sldMaster>
 </file>
@@ -8523,8 +8523,8 @@
           <p:nvPr/>
         </p:nvPicPr>
         <p:blipFill>
-          <a:blip ns3:embed="Rfa4f3dab6622409a"/>
-          <a:srcRect l="10091" t="0" r="10091" b="0"/>
+          <a:blip ns3:embed="Rdcebbe89e28f490c"/>
+          <a:srcRect l="0" t="0" r="0" b="0"/>
           <a:stretch>
             <a:fillRect l="0" t="0" r="0" b="0"/>
           </a:stretch>
@@ -8703,8 +8703,8 @@
           <p:nvPr/>
         </p:nvPicPr>
         <p:blipFill>
-          <a:blip ns3:embed="R90fd4562b74449e1"/>
-          <a:srcRect l="0" t="2" r="0" b="2"/>
+          <a:blip ns3:embed="Rb7c86ea21b054940"/>
+          <a:srcRect l="0" t="0" r="0" b="0"/>
           <a:stretch>
             <a:fillRect l="0" t="0" r="0" b="0"/>
           </a:stretch>
@@ -8883,8 +8883,8 @@
           <p:nvPr/>
         </p:nvPicPr>
         <p:blipFill>
-          <a:blip ns3:embed="Rf645ae31368d4866"/>
-          <a:srcRect l="0" t="2" r="0" b="2"/>
+          <a:blip ns3:embed="R3bf883589b5d4e97"/>
+          <a:srcRect l="0" t="0" r="0" b="0"/>
           <a:stretch>
             <a:fillRect l="0" t="0" r="0" b="0"/>
           </a:stretch>
@@ -9063,8 +9063,8 @@
           <p:nvPr/>
         </p:nvPicPr>
         <p:blipFill>
-          <a:blip ns3:embed="R31f7cadae9314834"/>
-          <a:srcRect l="0" t="2" r="0" b="2"/>
+          <a:blip ns3:embed="R7c48ea4cf3534abe"/>
+          <a:srcRect l="0" t="0" r="0" b="0"/>
           <a:stretch>
             <a:fillRect l="0" t="0" r="0" b="0"/>
           </a:stretch>
@@ -9243,8 +9243,8 @@
           <p:nvPr/>
         </p:nvPicPr>
         <p:blipFill>
-          <a:blip ns3:embed="R00ca465e016d4d74"/>
-          <a:srcRect l="10386" t="0" r="10386" b="0"/>
+          <a:blip ns3:embed="R8de58a41dc194e52"/>
+          <a:srcRect l="0" t="0" r="0" b="0"/>
           <a:stretch>
             <a:fillRect l="0" t="0" r="0" b="0"/>
           </a:stretch>

</xml_diff>